<commit_message>
feat: add PDF format pitch deck and demo accounts box to UI and presentation
</commit_message>
<xml_diff>
--- a/Pocketpay_Pitch_Deck.pptx
+++ b/Pocketpay_Pitch_Deck.pptx
@@ -3682,7 +3682,7 @@
             <a:avLst/>
           </a:prstGeom>
           <a:solidFill>
-            <a:srgbClr val="8B5CF6"/>
+            <a:srgbClr val="00F0FF"/>
           </a:solidFill>
           <a:ln>
             <a:noFill/>
@@ -3718,8 +3718,8 @@
         </p:nvSpPr>
         <p:spPr>
           <a:xfrm>
-            <a:off x="6446520" y="2194560"/>
-            <a:ext cx="4663440" cy="3566160"/>
+            <a:off x="6446520" y="2103120"/>
+            <a:ext cx="4663440" cy="3749040"/>
           </a:xfrm>
           <a:prstGeom prst="rect">
             <a:avLst/>
@@ -3735,7 +3735,7 @@
             <a:pPr>
               <a:defRPr sz="2000" b="1">
                 <a:solidFill>
-                  <a:srgbClr val="8B5CF6"/>
+                  <a:srgbClr val="00F0FF"/>
                 </a:solidFill>
               </a:defRPr>
             </a:pPr>
@@ -3745,22 +3745,22 @@
           </a:p>
           <a:p>
             <a:pPr>
-              <a:defRPr sz="1000" b="1">
+              <a:defRPr sz="950" b="1">
                 <a:solidFill>
                   <a:srgbClr val="FFFFFF"/>
                 </a:solidFill>
               </a:defRPr>
             </a:pPr>
             <a:r>
-              <a:t>SUBMISSION LINKS &amp; METRICS</a:t>
+              <a:t>SUBMISSION LINKS &amp; DEMO LOGINS</a:t>
             </a:r>
           </a:p>
           <a:p>
             <a:pPr>
               <a:spcBef>
-                <a:spcPts val="1200"/>
+                <a:spcPts val="800"/>
               </a:spcBef>
-              <a:defRPr sz="1200">
+              <a:defRPr sz="1100">
                 <a:solidFill>
                   <a:srgbClr val="94A3B8"/>
                 </a:solidFill>
@@ -3776,29 +3776,36 @@
             <a:br/>
             <a:br/>
             <a:r>
-              <a:t>• Live Local Demo Application:</a:t>
+              <a:t>• Live Local Demo Application: http://127.0.0.1:8000</a:t>
             </a:r>
             <a:br/>
             <a:r>
-              <a:t>  http://127.0.0.1:8000 (Alice: alice@demo.com)</a:t>
+              <a:t>• Interactive OpenAPI Swagger: http://127.0.0.1:8000/docs</a:t>
+            </a:r>
+            <a:br/>
+            <a:r>
+              <a:t>• Team: Nova (@novaecosystems), @architect, @implementer, @reviewer</a:t>
             </a:r>
             <a:br/>
             <a:br/>
             <a:r>
-              <a:t>• Interactive OpenAPI Swagger Documentation:</a:t>
+              <a:t>🔑 Pre-Seeded Demo Logins (Password for all: Password123!):</a:t>
             </a:r>
             <a:br/>
             <a:r>
-              <a:t>  http://127.0.0.1:8000/docs</a:t>
+              <a:t>  - Alice (@alice): alice@demo.com (€1,500.00 / Primary demo)</a:t>
             </a:r>
             <a:br/>
+            <a:r>
+              <a:t>  - Bob (@bob): bob@demo.com (€850.00 / P2P recipient)</a:t>
+            </a:r>
             <a:br/>
             <a:r>
-              <a:t>• Band Factory Team:</a:t>
+              <a:t>  - Carol (@carol): carol@demo.com (€500.00 / Split requester)</a:t>
             </a:r>
             <a:br/>
             <a:r>
-              <a:t>  Nova (@novaecosystems), @architect, @implementer, @reviewer</a:t>
+              <a:t>  *Sidebar click-to-fill active on login screen</a:t>
             </a:r>
           </a:p>
         </p:txBody>
@@ -7642,8 +7649,8 @@
         </p:nvSpPr>
         <p:spPr>
           <a:xfrm>
-            <a:off x="960120" y="2194560"/>
-            <a:ext cx="2871216" cy="3566160"/>
+            <a:off x="960120" y="2148840"/>
+            <a:ext cx="2871216" cy="3657600"/>
           </a:xfrm>
           <a:prstGeom prst="rect">
             <a:avLst/>
@@ -7657,7 +7664,7 @@
           <a:lstStyle/>
           <a:p>
             <a:pPr>
-              <a:defRPr sz="2200" b="1">
+              <a:defRPr sz="2000" b="1">
                 <a:solidFill>
                   <a:srgbClr val="10B981"/>
                 </a:solidFill>
@@ -7669,41 +7676,49 @@
           </a:p>
           <a:p>
             <a:pPr>
-              <a:defRPr sz="1000" b="1">
+              <a:defRPr sz="950" b="1">
                 <a:solidFill>
                   <a:srgbClr val="FFFFFF"/>
                 </a:solidFill>
               </a:defRPr>
             </a:pPr>
             <a:r>
-              <a:t>REAL-TIME BALANCES</a:t>
+              <a:t>REAL-TIME BALANCES &amp; ACTIVITY</a:t>
             </a:r>
           </a:p>
           <a:p>
             <a:pPr>
               <a:spcBef>
-                <a:spcPts val="1200"/>
+                <a:spcPts val="1000"/>
               </a:spcBef>
-              <a:defRPr sz="1200">
+              <a:defRPr sz="1100">
                 <a:solidFill>
                   <a:srgbClr val="94A3B8"/>
                 </a:solidFill>
               </a:defRPr>
             </a:pPr>
             <a:r>
-              <a:t>• Dynamic display: Total, Available, and Held funds</a:t>
+              <a:t>• Dynamic balance: Total, Available, Held</a:t>
             </a:r>
             <a:br/>
             <a:r>
-              <a:t>• Real-time P2P payments by handle</a:t>
+              <a:t>• Instant P2P payments by @handle</a:t>
             </a:r>
             <a:br/>
             <a:r>
-              <a:t>• Transaction activity feed with public/private notes</a:t>
+              <a:t>• Transaction activity feed with private notes</a:t>
             </a:r>
             <a:br/>
             <a:r>
-              <a:t>• Pre-seeded test accounts: alice, bob, carol</a:t>
+              <a:t>• High-concurrency SQLite WAL ledger</a:t>
+            </a:r>
+            <a:br/>
+            <a:r>
+              <a:t>• Export state &amp; system reset endpoints</a:t>
+            </a:r>
+            <a:br/>
+            <a:r>
+              <a:t>• Automated test-friendly data-testid tags</a:t>
             </a:r>
           </a:p>
         </p:txBody>
@@ -7804,8 +7819,8 @@
         </p:nvSpPr>
         <p:spPr>
           <a:xfrm>
-            <a:off x="4654296" y="2194560"/>
-            <a:ext cx="2871216" cy="3566160"/>
+            <a:off x="4654296" y="2148840"/>
+            <a:ext cx="2871216" cy="3657600"/>
           </a:xfrm>
           <a:prstGeom prst="rect">
             <a:avLst/>
@@ -7819,53 +7834,61 @@
           <a:lstStyle/>
           <a:p>
             <a:pPr>
-              <a:defRPr sz="2200" b="1">
+              <a:defRPr sz="2000" b="1">
                 <a:solidFill>
                   <a:srgbClr val="10B981"/>
                 </a:solidFill>
               </a:defRPr>
             </a:pPr>
             <a:r>
-              <a:t>Requests &amp; Splits</a:t>
-            </a:r>
-          </a:p>
-          <a:p>
-            <a:pPr>
-              <a:defRPr sz="1000" b="1">
+              <a:t>Requests &amp; Holds</a:t>
+            </a:r>
+          </a:p>
+          <a:p>
+            <a:pPr>
+              <a:defRPr sz="950" b="1">
                 <a:solidFill>
                   <a:srgbClr val="FFFFFF"/>
                 </a:solidFill>
               </a:defRPr>
             </a:pPr>
             <a:r>
-              <a:t>P2P BILL SHARING</a:t>
+              <a:t>P2P BILL SHARING &amp; TWO-PHASE APIS</a:t>
             </a:r>
           </a:p>
           <a:p>
             <a:pPr>
               <a:spcBef>
-                <a:spcPts val="1200"/>
+                <a:spcPts val="1000"/>
               </a:spcBef>
-              <a:defRPr sz="1200">
+              <a:defRPr sz="1100">
                 <a:solidFill>
                   <a:srgbClr val="94A3B8"/>
                 </a:solidFill>
               </a:defRPr>
             </a:pPr>
             <a:r>
-              <a:t>• Peer-to-peer payment requests (Pay, Decline, Cancel)</a:t>
+              <a:t>• P2P requests: Pay, Decline, and Cancel</a:t>
             </a:r>
             <a:br/>
             <a:r>
-              <a:t>• Multi-party bill splits with integer remainder distribution</a:t>
+              <a:t>• Multi-party bill splits with remainder handling</a:t>
             </a:r>
             <a:br/>
             <a:r>
-              <a:t>• Fully instrumented with semantic data-testid tags</a:t>
+              <a:t>• Merchant authorizations: 2-phase holds</a:t>
             </a:r>
             <a:br/>
             <a:r>
-              <a:t>• Responsive SSR HTML views</a:t>
+              <a:t>• Full &amp; partial capture, release/void</a:t>
+            </a:r>
+            <a:br/>
+            <a:r>
+              <a:t>• Interactive OpenAPI Swagger at /docs</a:t>
+            </a:r>
+            <a:br/>
+            <a:r>
+              <a:t>• Strict RFC 3339 timezone validation</a:t>
             </a:r>
           </a:p>
         </p:txBody>
@@ -7930,7 +7953,7 @@
             <a:avLst/>
           </a:prstGeom>
           <a:solidFill>
-            <a:srgbClr val="10B981"/>
+            <a:srgbClr val="00F0FF"/>
           </a:solidFill>
           <a:ln>
             <a:noFill/>
@@ -7966,8 +7989,8 @@
         </p:nvSpPr>
         <p:spPr>
           <a:xfrm>
-            <a:off x="8348472" y="2194560"/>
-            <a:ext cx="2871216" cy="3566160"/>
+            <a:off x="8275320" y="2103120"/>
+            <a:ext cx="3008376" cy="3794760"/>
           </a:xfrm>
           <a:prstGeom prst="rect">
             <a:avLst/>
@@ -7981,53 +8004,134 @@
           <a:lstStyle/>
           <a:p>
             <a:pPr>
-              <a:defRPr sz="2200" b="1">
+              <a:defRPr sz="2000" b="1">
+                <a:solidFill>
+                  <a:srgbClr val="00F0FF"/>
+                </a:solidFill>
+              </a:defRPr>
+            </a:pPr>
+            <a:r>
+              <a:t>🔑 Demo Accounts</a:t>
+            </a:r>
+          </a:p>
+          <a:p>
+            <a:pPr>
+              <a:defRPr sz="950" b="1">
+                <a:solidFill>
+                  <a:srgbClr val="FFFFFF"/>
+                </a:solidFill>
+              </a:defRPr>
+            </a:pPr>
+            <a:r>
+              <a:t>LOGIN PASSWORDS &amp; BALANCES</a:t>
+            </a:r>
+          </a:p>
+          <a:p>
+            <a:pPr>
+              <a:spcBef>
+                <a:spcPts val="600"/>
+              </a:spcBef>
+              <a:defRPr sz="1100" b="1">
+                <a:solidFill>
+                  <a:srgbClr val="00F0FF"/>
+                </a:solidFill>
+              </a:defRPr>
+            </a:pPr>
+            <a:r>
+              <a:t>Alice Demo (@alice) • €1,500.00</a:t>
+            </a:r>
+          </a:p>
+          <a:p>
+            <a:pPr>
+              <a:defRPr sz="950">
+                <a:solidFill>
+                  <a:srgbClr val="94A3B8"/>
+                </a:solidFill>
+              </a:defRPr>
+            </a:pPr>
+            <a:r>
+              <a:t>Email: alice@demo.com | Pass: Password123!</a:t>
+            </a:r>
+            <a:br/>
+            <a:r>
+              <a:t>Avail: €1,455.00 | Held: €45.00 (Active hold)</a:t>
+            </a:r>
+          </a:p>
+          <a:p>
+            <a:pPr>
+              <a:spcBef>
+                <a:spcPts val="600"/>
+              </a:spcBef>
+              <a:defRPr sz="1100" b="1">
                 <a:solidFill>
                   <a:srgbClr val="10B981"/>
                 </a:solidFill>
               </a:defRPr>
             </a:pPr>
             <a:r>
-              <a:t>Authorizations &amp; Docs</a:t>
-            </a:r>
-          </a:p>
-          <a:p>
-            <a:pPr>
-              <a:defRPr sz="1000" b="1">
-                <a:solidFill>
-                  <a:srgbClr val="FFFFFF"/>
-                </a:solidFill>
-              </a:defRPr>
-            </a:pPr>
-            <a:r>
-              <a:t>TWO-PHASE HOLDS &amp; APIS</a:t>
+              <a:t>Bob Demo (@bob) • €850.00</a:t>
+            </a:r>
+          </a:p>
+          <a:p>
+            <a:pPr>
+              <a:defRPr sz="950">
+                <a:solidFill>
+                  <a:srgbClr val="94A3B8"/>
+                </a:solidFill>
+              </a:defRPr>
+            </a:pPr>
+            <a:r>
+              <a:t>Email: bob@demo.com | Pass: Password123!</a:t>
+            </a:r>
+            <a:br/>
+            <a:r>
+              <a:t>Sent €25.00 dinner, pending concert split</a:t>
             </a:r>
           </a:p>
           <a:p>
             <a:pPr>
               <a:spcBef>
-                <a:spcPts val="1200"/>
+                <a:spcPts val="600"/>
               </a:spcBef>
-              <a:defRPr sz="1200">
+              <a:defRPr sz="1100" b="1">
+                <a:solidFill>
+                  <a:srgbClr val="F59E0B"/>
+                </a:solidFill>
+              </a:defRPr>
+            </a:pPr>
+            <a:r>
+              <a:t>Carol Demo (@carol) • €500.00</a:t>
+            </a:r>
+          </a:p>
+          <a:p>
+            <a:pPr>
+              <a:defRPr sz="950">
                 <a:solidFill>
                   <a:srgbClr val="94A3B8"/>
                 </a:solidFill>
               </a:defRPr>
             </a:pPr>
             <a:r>
-              <a:t>• Merchant holds: open, full/partial capture, void</a:t>
+              <a:t>Email: carol@demo.com | Pass: Password123!</a:t>
             </a:r>
             <a:br/>
             <a:r>
-              <a:t>• Interactive OpenAPI Swagger UI at /docs</a:t>
-            </a:r>
-            <a:br/>
-            <a:r>
-              <a:t>• Automated state export and reset endpoints</a:t>
-            </a:r>
-            <a:br/>
-            <a:r>
-              <a:t>• Strict RFC 3339 timezone validation</a:t>
+              <a:t>Fresh wallet, incoming €18.00 coffee request</a:t>
+            </a:r>
+          </a:p>
+          <a:p>
+            <a:pPr>
+              <a:spcBef>
+                <a:spcPts val="600"/>
+              </a:spcBef>
+              <a:defRPr sz="950" b="1">
+                <a:solidFill>
+                  <a:srgbClr val="00F0FF"/>
+                </a:solidFill>
+              </a:defRPr>
+            </a:pPr>
+            <a:r>
+              <a:t>⚡ Click-to-fill enabled in UI login side box</a:t>
             </a:r>
           </a:p>
         </p:txBody>
@@ -8062,7 +8166,7 @@
               </a:defRPr>
             </a:pPr>
             <a:r>
-              <a:t>Live Demo Server: http://127.0.0.1:8000</a:t>
+              <a:t>Live Demo Server: http://127.0.0.1:8000/login</a:t>
             </a:r>
             <a:r>
               <a:rPr sz="1000">
@@ -8070,7 +8174,7 @@
                   <a:srgbClr val="64748B"/>
                 </a:solidFill>
               </a:rPr>
-              <a:t>                                                                               Credentials: alice@demo.com / Password123!</a:t>
+              <a:t>                                                                               Auto-fill side box enabled • All Demo Passwords: Password123!</a:t>
             </a:r>
           </a:p>
         </p:txBody>

</xml_diff>

<commit_message>
feat(deploy): configure and deploy Pocketpay on Vercel with live demo and pitch deck updates
</commit_message>
<xml_diff>
--- a/Pocketpay_Pitch_Deck.pptx
+++ b/Pocketpay_Pitch_Deck.pptx
@@ -3776,11 +3776,15 @@
             <a:br/>
             <a:br/>
             <a:r>
-              <a:t>• Live Local Demo Application: http://127.0.0.1:8000</a:t>
+              <a:t>• Live Vercel Deployment: https://temporary-turbo-carbon-owriola.vercel.app</a:t>
             </a:r>
             <a:br/>
             <a:r>
-              <a:t>• Interactive OpenAPI Swagger: http://127.0.0.1:8000/docs</a:t>
+              <a:t>• Live Demo Login: https://temporary-turbo-carbon-owriola.vercel.app/login</a:t>
+            </a:r>
+            <a:br/>
+            <a:r>
+              <a:t>• Interactive OpenAPI Swagger: https://temporary-turbo-carbon-owriola.vercel.app/docs</a:t>
             </a:r>
             <a:br/>
             <a:r>
@@ -8166,7 +8170,7 @@
               </a:defRPr>
             </a:pPr>
             <a:r>
-              <a:t>Live Demo Server: http://127.0.0.1:8000/login</a:t>
+              <a:t>Live Vercel Demo: https://temporary-turbo-carbon-owriola.vercel.app/login</a:t>
             </a:r>
             <a:r>
               <a:rPr sz="1000">

</xml_diff>